<commit_message>
System Design 101 (vi): qualify shared-library memory in sd-08-019, expected-count model in sd-08-018, bounds in sd-08-020
Co-Authored-By: Claude Sonnet 5.5 <noreply@anthropic.com>
Claude-Session: https://claude.ai/code/session_01DkN7YTqFfdjb8A8J5ehSWS
</commit_message>
<xml_diff>
--- a/system-design-101/vi/lessons/sd-08-018/slides/sd-08-018.pptx
+++ b/system-design-101/vi/lessons/sd-08-018/slides/sd-08-018.pptx
@@ -7547,7 +7547,40 @@
                 <a:ea typeface="Be Vietnam Pro" pitchFamily="34" charset="-122"/>
                 <a:cs typeface="Be Vietnam Pro" pitchFamily="34" charset="-120"/>
               </a:rPr>
-              <a:t> MÔ</a:t>
+              <a:t> MÔ HÌNH,</a:t>
+            </a:r>
+            <a:r>
+              <a:rPr lang="en-US" sz="1800" b="1" spc="309" kern="0" dirty="0">
+                <a:solidFill>
+                  <a:srgbClr val="1F3FD1"/>
+                </a:solidFill>
+                <a:latin typeface="Be Vietnam Pro" pitchFamily="34" charset="0"/>
+                <a:ea typeface="Be Vietnam Pro" pitchFamily="34" charset="-122"/>
+                <a:cs typeface="Be Vietnam Pro" pitchFamily="34" charset="-120"/>
+              </a:rPr>
+              <a:t> SỐ</a:t>
+            </a:r>
+            <a:r>
+              <a:rPr lang="en-US" sz="1800" b="1" spc="281" kern="0" dirty="0">
+                <a:solidFill>
+                  <a:srgbClr val="1F3FD1"/>
+                </a:solidFill>
+                <a:latin typeface="Be Vietnam Pro" pitchFamily="34" charset="0"/>
+                <a:ea typeface="Be Vietnam Pro" pitchFamily="34" charset="-122"/>
+                <a:cs typeface="Be Vietnam Pro" pitchFamily="34" charset="-120"/>
+              </a:rPr>
+              <a:t> BÁO</a:t>
+            </a:r>
+            <a:r>
+              <a:rPr lang="en-US" sz="1800" b="1" spc="268" kern="0" dirty="0">
+                <a:solidFill>
+                  <a:srgbClr val="1F3FD1"/>
+                </a:solidFill>
+                <a:latin typeface="Be Vietnam Pro" pitchFamily="34" charset="0"/>
+                <a:ea typeface="Be Vietnam Pro" pitchFamily="34" charset="-122"/>
+                <a:cs typeface="Be Vietnam Pro" pitchFamily="34" charset="-120"/>
+              </a:rPr>
+              <a:t> CÁO</a:t>
             </a:r>
             <a:r>
               <a:rPr lang="en-US" sz="1800" b="1" spc="302" kern="0" dirty="0">
@@ -7558,10 +7591,10 @@
                 <a:ea typeface="Be Vietnam Pro" pitchFamily="34" charset="-122"/>
                 <a:cs typeface="Be Vietnam Pro" pitchFamily="34" charset="-120"/>
               </a:rPr>
-              <a:t> HÌNH</a:t>
-            </a:r>
-            <a:r>
-              <a:rPr lang="en-US" sz="1800" b="1" spc="263" kern="0" dirty="0">
+              <a:t> KỲ</a:t>
+            </a:r>
+            <a:r>
+              <a:rPr lang="en-US" sz="1800" b="1" spc="294" kern="0" dirty="0">
                 <a:solidFill>
                   <a:srgbClr val="1F3FD1"/>
                 </a:solidFill>
@@ -7569,40 +7602,7 @@
                 <a:ea typeface="Be Vietnam Pro" pitchFamily="34" charset="-122"/>
                 <a:cs typeface="Be Vietnam Pro" pitchFamily="34" charset="-120"/>
               </a:rPr>
-              <a:t> PHÁT</a:t>
-            </a:r>
-            <a:r>
-              <a:rPr lang="en-US" sz="1800" b="1" spc="301" kern="0" dirty="0">
-                <a:solidFill>
-                  <a:srgbClr val="1F3FD1"/>
-                </a:solidFill>
-                <a:latin typeface="Be Vietnam Pro" pitchFamily="34" charset="0"/>
-                <a:ea typeface="Be Vietnam Pro" pitchFamily="34" charset="-122"/>
-                <a:cs typeface="Be Vietnam Pro" pitchFamily="34" charset="-120"/>
-              </a:rPr>
-              <a:t> HÀNH</a:t>
-            </a:r>
-            <a:r>
-              <a:rPr lang="en-US" sz="1800" b="1" spc="298" kern="0" dirty="0">
-                <a:solidFill>
-                  <a:srgbClr val="1F3FD1"/>
-                </a:solidFill>
-                <a:latin typeface="Be Vietnam Pro" pitchFamily="34" charset="0"/>
-                <a:ea typeface="Be Vietnam Pro" pitchFamily="34" charset="-122"/>
-                <a:cs typeface="Be Vietnam Pro" pitchFamily="34" charset="-120"/>
-              </a:rPr>
-              <a:t> THEO</a:t>
-            </a:r>
-            <a:r>
-              <a:rPr lang="en-US" sz="1800" b="1" spc="300" kern="0" dirty="0">
-                <a:solidFill>
-                  <a:srgbClr val="1F3FD1"/>
-                </a:solidFill>
-                <a:latin typeface="Be Vietnam Pro" pitchFamily="34" charset="0"/>
-                <a:ea typeface="Be Vietnam Pro" pitchFamily="34" charset="-122"/>
-                <a:cs typeface="Be Vietnam Pro" pitchFamily="34" charset="-120"/>
-              </a:rPr>
-              <a:t> PHA</a:t>
+              <a:t> VỌNG</a:t>
             </a:r>
             <a:endParaRPr lang="en-US" sz="1800" dirty="0"/>
           </a:p>

</xml_diff>